<commit_message>
Updates based on 2025-11-24 team call
</commit_message>
<xml_diff>
--- a/vsp/docs/VSM_UI Proposal.pptx
+++ b/vsp/docs/VSM_UI Proposal.pptx
@@ -306,7 +306,7 @@
           <a:p>
             <a:fld id="{5BCAD085-E8A6-8845-BD4E-CB4CCA059FC4}" type="datetimeFigureOut">
               <a:rPr lang="en-US" smtClean="0"/>
-              <a:t>11/21/2025</a:t>
+              <a:t>11/24/2025</a:t>
             </a:fld>
             <a:endParaRPr lang="en-US"/>
           </a:p>
@@ -474,7 +474,7 @@
           <a:p>
             <a:fld id="{5BCAD085-E8A6-8845-BD4E-CB4CCA059FC4}" type="datetimeFigureOut">
               <a:rPr lang="en-US" smtClean="0"/>
-              <a:t>11/21/2025</a:t>
+              <a:t>11/24/2025</a:t>
             </a:fld>
             <a:endParaRPr lang="en-US"/>
           </a:p>
@@ -652,7 +652,7 @@
           <a:p>
             <a:fld id="{5BCAD085-E8A6-8845-BD4E-CB4CCA059FC4}" type="datetimeFigureOut">
               <a:rPr lang="en-US" smtClean="0"/>
-              <a:t>11/21/2025</a:t>
+              <a:t>11/24/2025</a:t>
             </a:fld>
             <a:endParaRPr lang="en-US"/>
           </a:p>
@@ -820,7 +820,7 @@
           <a:p>
             <a:fld id="{5BCAD085-E8A6-8845-BD4E-CB4CCA059FC4}" type="datetimeFigureOut">
               <a:rPr lang="en-US" smtClean="0"/>
-              <a:t>11/21/2025</a:t>
+              <a:t>11/24/2025</a:t>
             </a:fld>
             <a:endParaRPr lang="en-US"/>
           </a:p>
@@ -1065,7 +1065,7 @@
           <a:p>
             <a:fld id="{5BCAD085-E8A6-8845-BD4E-CB4CCA059FC4}" type="datetimeFigureOut">
               <a:rPr lang="en-US" smtClean="0"/>
-              <a:t>11/21/2025</a:t>
+              <a:t>11/24/2025</a:t>
             </a:fld>
             <a:endParaRPr lang="en-US"/>
           </a:p>
@@ -1350,7 +1350,7 @@
           <a:p>
             <a:fld id="{5BCAD085-E8A6-8845-BD4E-CB4CCA059FC4}" type="datetimeFigureOut">
               <a:rPr lang="en-US" smtClean="0"/>
-              <a:t>11/21/2025</a:t>
+              <a:t>11/24/2025</a:t>
             </a:fld>
             <a:endParaRPr lang="en-US"/>
           </a:p>
@@ -1769,7 +1769,7 @@
           <a:p>
             <a:fld id="{5BCAD085-E8A6-8845-BD4E-CB4CCA059FC4}" type="datetimeFigureOut">
               <a:rPr lang="en-US" smtClean="0"/>
-              <a:t>11/21/2025</a:t>
+              <a:t>11/24/2025</a:t>
             </a:fld>
             <a:endParaRPr lang="en-US"/>
           </a:p>
@@ -1886,7 +1886,7 @@
           <a:p>
             <a:fld id="{5BCAD085-E8A6-8845-BD4E-CB4CCA059FC4}" type="datetimeFigureOut">
               <a:rPr lang="en-US" smtClean="0"/>
-              <a:t>11/21/2025</a:t>
+              <a:t>11/24/2025</a:t>
             </a:fld>
             <a:endParaRPr lang="en-US"/>
           </a:p>
@@ -1981,7 +1981,7 @@
           <a:p>
             <a:fld id="{5BCAD085-E8A6-8845-BD4E-CB4CCA059FC4}" type="datetimeFigureOut">
               <a:rPr lang="en-US" smtClean="0"/>
-              <a:t>11/21/2025</a:t>
+              <a:t>11/24/2025</a:t>
             </a:fld>
             <a:endParaRPr lang="en-US"/>
           </a:p>
@@ -2256,7 +2256,7 @@
           <a:p>
             <a:fld id="{5BCAD085-E8A6-8845-BD4E-CB4CCA059FC4}" type="datetimeFigureOut">
               <a:rPr lang="en-US" smtClean="0"/>
-              <a:t>11/21/2025</a:t>
+              <a:t>11/24/2025</a:t>
             </a:fld>
             <a:endParaRPr lang="en-US"/>
           </a:p>
@@ -2508,7 +2508,7 @@
           <a:p>
             <a:fld id="{5BCAD085-E8A6-8845-BD4E-CB4CCA059FC4}" type="datetimeFigureOut">
               <a:rPr lang="en-US" smtClean="0"/>
-              <a:t>11/21/2025</a:t>
+              <a:t>11/24/2025</a:t>
             </a:fld>
             <a:endParaRPr lang="en-US"/>
           </a:p>
@@ -2719,7 +2719,7 @@
           <a:p>
             <a:fld id="{5BCAD085-E8A6-8845-BD4E-CB4CCA059FC4}" type="datetimeFigureOut">
               <a:rPr lang="en-US" smtClean="0"/>
-              <a:t>11/21/2025</a:t>
+              <a:t>11/24/2025</a:t>
             </a:fld>
             <a:endParaRPr lang="en-US"/>
           </a:p>
@@ -3249,7 +3249,7 @@
         </p:spPr>
         <p:txBody>
           <a:bodyPr vert="horz" lIns="91440" tIns="45720" rIns="91440" bIns="45720" rtlCol="0" anchor="ctr">
-            <a:normAutofit fontScale="92500" lnSpcReduction="10000"/>
+            <a:normAutofit fontScale="85000" lnSpcReduction="20000"/>
           </a:bodyPr>
           <a:lstStyle>
             <a:lvl1pPr algn="ctr" defTabSz="457200" rtl="0" eaLnBrk="1" latinLnBrk="0" hangingPunct="1">
@@ -3284,19 +3284,11 @@
             </a:pPr>
             <a:r>
               <a:rPr lang="en-US" sz="1400" b="1" dirty="0"/>
-              <a:t>Create/Search Value Set Refresh Package</a:t>
+              <a:t>Value Set Packages</a:t>
             </a:r>
             <a:r>
               <a:rPr lang="en-US" sz="1400" dirty="0"/>
-              <a:t> – Select an IG from the dropdown to filter the list of packages. If no records are found, a </a:t>
-            </a:r>
-            <a:r>
-              <a:rPr lang="en-US" sz="1400" b="1" dirty="0"/>
-              <a:t>Create</a:t>
-            </a:r>
-            <a:r>
-              <a:rPr lang="en-US" sz="1400" dirty="0"/>
-              <a:t> button should appear, allowing the user to create a new value set package based on the selected IG. After creation, the user should be taken to the Value Set Packages tab.</a:t>
+              <a:t> – Same as the Programs page, but it is showing only Value Set Packages</a:t>
             </a:r>
           </a:p>
           <a:p>
@@ -3308,10 +3300,38 @@
               <a:buChar char="•"/>
             </a:pPr>
             <a:r>
+              <a:rPr lang="en-US" sz="1400" dirty="0"/>
+              <a:t>Select Implementation Guide is a filter displaying known implementation guides</a:t>
+            </a:r>
+          </a:p>
+          <a:p>
+            <a:pPr marL="342900" indent="-342900" algn="just">
+              <a:lnSpc>
+                <a:spcPct val="120000"/>
+              </a:lnSpc>
+              <a:buFont typeface="Arial" panose="020B0604020202020204" pitchFamily="34" charset="0"/>
+              <a:buChar char="•"/>
+            </a:pPr>
+            <a:r>
               <a:rPr lang="en-US" sz="1400" dirty="0">
                 <a:latin typeface="+mn-lt"/>
               </a:rPr>
-              <a:t>If it exists, show Draft + Active version.</a:t>
+              <a:t>Display Draft + Active versions on this authoring page</a:t>
+            </a:r>
+          </a:p>
+          <a:p>
+            <a:pPr marL="342900" indent="-342900" algn="just">
+              <a:lnSpc>
+                <a:spcPct val="120000"/>
+              </a:lnSpc>
+              <a:buFont typeface="Arial" panose="020B0604020202020204" pitchFamily="34" charset="0"/>
+              <a:buChar char="•"/>
+            </a:pPr>
+            <a:r>
+              <a:rPr lang="en-US" sz="1400" dirty="0">
+                <a:latin typeface="+mn-lt"/>
+              </a:rPr>
+              <a:t>Create creates a Value Set Package for the selected implementation guide (choose one or disable if none selected), and then takes the user to the Value Set Package Edit</a:t>
             </a:r>
             <a:endParaRPr lang="en-US" sz="1100" dirty="0">
               <a:latin typeface="+mn-lt"/>
@@ -3457,7 +3477,7 @@
             <a:pPr algn="ctr"/>
             <a:r>
               <a:rPr lang="en-US" dirty="0"/>
-              <a:t>Tab: Value Set Refresh Packages</a:t>
+              <a:t>Tab: Value Set Packages</a:t>
             </a:r>
           </a:p>
         </p:txBody>
@@ -3677,6 +3697,53 @@
           </a:fontRef>
         </p:style>
       </p:cxnSp>
+      <p:sp>
+        <p:nvSpPr>
+          <p:cNvPr id="2" name="Rectangle 1">
+            <a:extLst>
+              <a:ext uri="{FF2B5EF4-FFF2-40B4-BE49-F238E27FC236}">
+                <a16:creationId xmlns:a16="http://schemas.microsoft.com/office/drawing/2014/main" id="{76D42D34-64FA-B0FE-4702-43CBCF88FF35}"/>
+              </a:ext>
+            </a:extLst>
+          </p:cNvPr>
+          <p:cNvSpPr/>
+          <p:nvPr/>
+        </p:nvSpPr>
+        <p:spPr>
+          <a:xfrm>
+            <a:off x="5800725" y="3882118"/>
+            <a:ext cx="1114425" cy="286757"/>
+          </a:xfrm>
+          <a:prstGeom prst="rect">
+            <a:avLst/>
+          </a:prstGeom>
+        </p:spPr>
+        <p:style>
+          <a:lnRef idx="1">
+            <a:schemeClr val="accent1"/>
+          </a:lnRef>
+          <a:fillRef idx="3">
+            <a:schemeClr val="accent1"/>
+          </a:fillRef>
+          <a:effectRef idx="2">
+            <a:schemeClr val="accent1"/>
+          </a:effectRef>
+          <a:fontRef idx="minor">
+            <a:schemeClr val="lt1"/>
+          </a:fontRef>
+        </p:style>
+        <p:txBody>
+          <a:bodyPr rtlCol="0" anchor="ctr"/>
+          <a:lstStyle/>
+          <a:p>
+            <a:pPr algn="ctr"/>
+            <a:r>
+              <a:rPr lang="en-US" dirty="0"/>
+              <a:t>Create</a:t>
+            </a:r>
+          </a:p>
+        </p:txBody>
+      </p:sp>
     </p:spTree>
     <p:extLst>
       <p:ext uri="{BB962C8B-B14F-4D97-AF65-F5344CB8AC3E}">
@@ -3738,7 +3805,7 @@
         </p:spPr>
         <p:txBody>
           <a:bodyPr vert="horz" lIns="91440" tIns="45720" rIns="91440" bIns="45720" rtlCol="0" anchor="ctr">
-            <a:normAutofit fontScale="55000" lnSpcReduction="20000"/>
+            <a:normAutofit fontScale="40000" lnSpcReduction="20000"/>
           </a:bodyPr>
           <a:lstStyle>
             <a:lvl1pPr algn="ctr" defTabSz="457200" rtl="0" eaLnBrk="1" latinLnBrk="0" hangingPunct="1">
@@ -3773,11 +3840,24 @@
             </a:pPr>
             <a:r>
               <a:rPr lang="en-US" sz="2900" b="1" dirty="0"/>
-              <a:t>Value Set Refresh Packages </a:t>
+              <a:t>Value Set Package Edit </a:t>
             </a:r>
             <a:r>
               <a:rPr lang="en-US" sz="2900" dirty="0"/>
-              <a:t>– The IG selected from the dropdown from previous tab should auto-populate the IG field, and once the user provides the Program Metadata and Program Manifest, a value set package will be created for that IG in draft status.</a:t>
+              <a:t>– The IG selected from the dropdown from previous tab should auto-populate the IG field, and once the user provides the Program Metadata (defaulted to data from the implementation guide (e.g. Value Set Package for &lt;implementation guide description&gt;), a value set package will be created for that IG in draft status.</a:t>
+            </a:r>
+          </a:p>
+          <a:p>
+            <a:pPr marL="342900" indent="-342900" algn="just">
+              <a:lnSpc>
+                <a:spcPct val="120000"/>
+              </a:lnSpc>
+              <a:buFont typeface="Arial" panose="020B0604020202020204" pitchFamily="34" charset="0"/>
+              <a:buChar char="•"/>
+            </a:pPr>
+            <a:r>
+              <a:rPr lang="en-US" sz="2900" dirty="0"/>
+              <a:t>Manifest will be defaulted to information available from the implementation guide expansion parameters</a:t>
             </a:r>
             <a:endParaRPr lang="en-US" sz="2500" dirty="0"/>
           </a:p>
@@ -4677,7 +4757,7 @@
         <p:spPr>
           <a:xfrm>
             <a:off x="255639" y="1857324"/>
-            <a:ext cx="8598924" cy="1200329"/>
+            <a:ext cx="8598924" cy="1754326"/>
           </a:xfrm>
           <a:prstGeom prst="rect">
             <a:avLst/>
@@ -4696,7 +4776,7 @@
             </a:pPr>
             <a:r>
               <a:rPr lang="en-US" dirty="0"/>
-              <a:t>Search the list of active programs by IG</a:t>
+              <a:t>Search the list of active value set packages by IG</a:t>
             </a:r>
           </a:p>
           <a:p>
@@ -4706,7 +4786,7 @@
             </a:pPr>
             <a:r>
               <a:rPr lang="en-US" dirty="0"/>
-              <a:t>Click on Any Program to review Package Details, </a:t>
+              <a:t>Click on Any Value Set Package to review Package Details, </a:t>
             </a:r>
             <a:r>
               <a:rPr lang="en-US" dirty="0" err="1"/>
@@ -4724,7 +4804,17 @@
             </a:pPr>
             <a:r>
               <a:rPr lang="en-US" dirty="0"/>
-              <a:t>From inside the Program, Export – Download the value sets expansions.</a:t>
+              <a:t>From inside the Value Set Package, Export – Download the value sets expansions.</a:t>
+            </a:r>
+          </a:p>
+          <a:p>
+            <a:pPr marL="285750" indent="-285750">
+              <a:buFont typeface="Arial" panose="020B0604020202020204" pitchFamily="34" charset="0"/>
+              <a:buChar char="•"/>
+            </a:pPr>
+            <a:r>
+              <a:rPr lang="en-US" dirty="0"/>
+              <a:t>Implementers can only view details, compare versions, view value sets and export</a:t>
             </a:r>
           </a:p>
           <a:p>

</xml_diff>

<commit_message>
refined wireframes as per discussion
</commit_message>
<xml_diff>
--- a/vsp/docs/VSM_UI Proposal.pptx
+++ b/vsp/docs/VSM_UI Proposal.pptx
@@ -3173,6 +3173,36 @@
           <a:chExt cx="0" cy="0"/>
         </a:xfrm>
       </p:grpSpPr>
+      <p:pic>
+        <p:nvPicPr>
+          <p:cNvPr id="5" name="Picture 4">
+            <a:extLst>
+              <a:ext uri="{FF2B5EF4-FFF2-40B4-BE49-F238E27FC236}">
+                <a16:creationId xmlns:a16="http://schemas.microsoft.com/office/drawing/2014/main" id="{BB506ABE-A9E6-F100-20E5-35A71DDFC2F3}"/>
+              </a:ext>
+            </a:extLst>
+          </p:cNvPr>
+          <p:cNvPicPr>
+            <a:picLocks noChangeAspect="1"/>
+          </p:cNvPicPr>
+          <p:nvPr/>
+        </p:nvPicPr>
+        <p:blipFill>
+          <a:blip r:embed="rId2"/>
+          <a:stretch>
+            <a:fillRect/>
+          </a:stretch>
+        </p:blipFill>
+        <p:spPr>
+          <a:xfrm>
+            <a:off x="0" y="3110265"/>
+            <a:ext cx="9144000" cy="3394436"/>
+          </a:xfrm>
+          <a:prstGeom prst="rect">
+            <a:avLst/>
+          </a:prstGeom>
+        </p:spPr>
+      </p:pic>
       <p:sp>
         <p:nvSpPr>
           <p:cNvPr id="3" name="Title 1">
@@ -3331,7 +3361,7 @@
               <a:rPr lang="en-US" sz="1400" dirty="0">
                 <a:latin typeface="+mn-lt"/>
               </a:rPr>
-              <a:t>Create creates a Value Set Package for the selected implementation guide (choose one or disable if none selected), and then takes the user to the Value Set Package Edit</a:t>
+              <a:t>Create a Value Set Package for the selected implementation guide (choose one or disable if none selected), and then takes the user to the Value Set Package Edit</a:t>
             </a:r>
             <a:endParaRPr lang="en-US" sz="1100" dirty="0">
               <a:latin typeface="+mn-lt"/>
@@ -3350,13 +3380,14 @@
           </p:cNvPr>
           <p:cNvCxnSpPr>
             <a:cxnSpLocks/>
+            <a:stCxn id="26" idx="2"/>
           </p:cNvCxnSpPr>
           <p:nvPr/>
         </p:nvCxnSpPr>
         <p:spPr>
-          <a:xfrm flipH="1">
-            <a:off x="2133600" y="2871673"/>
-            <a:ext cx="540773" cy="1316869"/>
+          <a:xfrm>
+            <a:off x="1337189" y="2635323"/>
+            <a:ext cx="766917" cy="1150096"/>
           </a:xfrm>
           <a:prstGeom prst="straightConnector1">
             <a:avLst/>
@@ -3394,8 +3425,8 @@
         </p:nvSpPr>
         <p:spPr>
           <a:xfrm>
-            <a:off x="4149214" y="2255549"/>
-            <a:ext cx="4763729" cy="411381"/>
+            <a:off x="2893759" y="2226330"/>
+            <a:ext cx="3824743" cy="411381"/>
           </a:xfrm>
           <a:prstGeom prst="rect">
             <a:avLst/>
@@ -3422,15 +3453,7 @@
             <a:pPr algn="ctr"/>
             <a:r>
               <a:rPr lang="en-US" dirty="0"/>
-              <a:t>Dropdown: </a:t>
-            </a:r>
-            <a:r>
-              <a:rPr lang="en-US" dirty="0" err="1"/>
-              <a:t>Implmenetation</a:t>
-            </a:r>
-            <a:r>
-              <a:rPr lang="en-US" dirty="0"/>
-              <a:t> Guide (IG) Filter</a:t>
+              <a:t>Dropdown: Implementation Guide (IG)</a:t>
             </a:r>
           </a:p>
         </p:txBody>
@@ -3449,8 +3472,8 @@
         </p:nvSpPr>
         <p:spPr>
           <a:xfrm>
-            <a:off x="358877" y="2282171"/>
-            <a:ext cx="3249561" cy="411380"/>
+            <a:off x="29499" y="2223943"/>
+            <a:ext cx="2615380" cy="411380"/>
           </a:xfrm>
           <a:prstGeom prst="rect">
             <a:avLst/>
@@ -3482,46 +3505,6 @@
           </a:p>
         </p:txBody>
       </p:sp>
-      <p:pic>
-        <p:nvPicPr>
-          <p:cNvPr id="27" name="Picture 26">
-            <a:extLst>
-              <a:ext uri="{FF2B5EF4-FFF2-40B4-BE49-F238E27FC236}">
-                <a16:creationId xmlns:a16="http://schemas.microsoft.com/office/drawing/2014/main" id="{47CB3515-C8B2-5DE7-A224-9CD06790CB62}"/>
-              </a:ext>
-            </a:extLst>
-          </p:cNvPr>
-          <p:cNvPicPr>
-            <a:picLocks noChangeAspect="1"/>
-          </p:cNvPicPr>
-          <p:nvPr/>
-        </p:nvPicPr>
-        <p:blipFill>
-          <a:blip r:embed="rId2"/>
-          <a:stretch>
-            <a:fillRect/>
-          </a:stretch>
-        </p:blipFill>
-        <p:spPr>
-          <a:xfrm>
-            <a:off x="358877" y="2940242"/>
-            <a:ext cx="8167087" cy="3643120"/>
-          </a:xfrm>
-          <a:prstGeom prst="rect">
-            <a:avLst/>
-          </a:prstGeom>
-          <a:ln>
-            <a:noFill/>
-          </a:ln>
-          <a:effectLst>
-            <a:outerShdw blurRad="292100" dist="139700" dir="2700000" algn="tl" rotWithShape="0">
-              <a:srgbClr val="333333">
-                <a:alpha val="65000"/>
-              </a:srgbClr>
-            </a:outerShdw>
-          </a:effectLst>
-        </p:spPr>
-      </p:pic>
       <p:cxnSp>
         <p:nvCxnSpPr>
           <p:cNvPr id="28" name="Straight Arrow Connector 27">
@@ -3538,8 +3521,8 @@
         </p:nvCxnSpPr>
         <p:spPr>
           <a:xfrm flipH="1">
-            <a:off x="4149214" y="2711693"/>
-            <a:ext cx="422786" cy="1117968"/>
+            <a:off x="4515465" y="2485550"/>
+            <a:ext cx="56535" cy="1299869"/>
           </a:xfrm>
           <a:prstGeom prst="straightConnector1">
             <a:avLst/>
@@ -3577,8 +3560,8 @@
         </p:nvSpPr>
         <p:spPr>
           <a:xfrm>
-            <a:off x="2467897" y="3849328"/>
-            <a:ext cx="3077497" cy="319547"/>
+            <a:off x="3878827" y="3860458"/>
+            <a:ext cx="1273276" cy="319547"/>
           </a:xfrm>
           <a:prstGeom prst="rect">
             <a:avLst/>
@@ -3604,7 +3587,7 @@
           <a:p>
             <a:r>
               <a:rPr lang="en-US" sz="1400" b="1" dirty="0"/>
-              <a:t>Select Implementation Guide (IG)</a:t>
+              <a:t>Select IG</a:t>
             </a:r>
           </a:p>
         </p:txBody>
@@ -3623,8 +3606,8 @@
         </p:nvSpPr>
         <p:spPr>
           <a:xfrm rot="5400000">
-            <a:off x="5310279" y="3918898"/>
-            <a:ext cx="155602" cy="180406"/>
+            <a:off x="4896464" y="3942039"/>
+            <a:ext cx="155601" cy="159028"/>
           </a:xfrm>
           <a:prstGeom prst="homePlate">
             <a:avLst/>
@@ -3655,25 +3638,169 @@
           </a:p>
         </p:txBody>
       </p:sp>
+      <p:sp>
+        <p:nvSpPr>
+          <p:cNvPr id="2" name="Rectangle 1">
+            <a:extLst>
+              <a:ext uri="{FF2B5EF4-FFF2-40B4-BE49-F238E27FC236}">
+                <a16:creationId xmlns:a16="http://schemas.microsoft.com/office/drawing/2014/main" id="{76D42D34-64FA-B0FE-4702-43CBCF88FF35}"/>
+              </a:ext>
+            </a:extLst>
+          </p:cNvPr>
+          <p:cNvSpPr/>
+          <p:nvPr/>
+        </p:nvSpPr>
+        <p:spPr>
+          <a:xfrm>
+            <a:off x="5770918" y="3955975"/>
+            <a:ext cx="1114425" cy="286757"/>
+          </a:xfrm>
+          <a:prstGeom prst="rect">
+            <a:avLst/>
+          </a:prstGeom>
+        </p:spPr>
+        <p:style>
+          <a:lnRef idx="1">
+            <a:schemeClr val="accent1"/>
+          </a:lnRef>
+          <a:fillRef idx="3">
+            <a:schemeClr val="accent1"/>
+          </a:fillRef>
+          <a:effectRef idx="2">
+            <a:schemeClr val="accent1"/>
+          </a:effectRef>
+          <a:fontRef idx="minor">
+            <a:schemeClr val="lt1"/>
+          </a:fontRef>
+        </p:style>
+        <p:txBody>
+          <a:bodyPr rtlCol="0" anchor="ctr"/>
+          <a:lstStyle/>
+          <a:p>
+            <a:pPr algn="ctr"/>
+            <a:r>
+              <a:rPr lang="en-US" dirty="0"/>
+              <a:t>Create</a:t>
+            </a:r>
+          </a:p>
+        </p:txBody>
+      </p:sp>
+      <p:sp>
+        <p:nvSpPr>
+          <p:cNvPr id="7" name="Rectangle 6">
+            <a:extLst>
+              <a:ext uri="{FF2B5EF4-FFF2-40B4-BE49-F238E27FC236}">
+                <a16:creationId xmlns:a16="http://schemas.microsoft.com/office/drawing/2014/main" id="{91B5273F-9A91-7E73-0321-C78006B9AD03}"/>
+              </a:ext>
+            </a:extLst>
+          </p:cNvPr>
+          <p:cNvSpPr/>
+          <p:nvPr/>
+        </p:nvSpPr>
+        <p:spPr>
+          <a:xfrm>
+            <a:off x="3878827" y="4180005"/>
+            <a:ext cx="1273276" cy="319547"/>
+          </a:xfrm>
+          <a:prstGeom prst="rect">
+            <a:avLst/>
+          </a:prstGeom>
+        </p:spPr>
+        <p:style>
+          <a:lnRef idx="1">
+            <a:schemeClr val="accent1"/>
+          </a:lnRef>
+          <a:fillRef idx="3">
+            <a:schemeClr val="accent1"/>
+          </a:fillRef>
+          <a:effectRef idx="2">
+            <a:schemeClr val="accent1"/>
+          </a:effectRef>
+          <a:fontRef idx="minor">
+            <a:schemeClr val="lt1"/>
+          </a:fontRef>
+        </p:style>
+        <p:txBody>
+          <a:bodyPr rtlCol="0" anchor="ctr"/>
+          <a:lstStyle/>
+          <a:p>
+            <a:r>
+              <a:rPr lang="en-US" sz="1400" b="1" dirty="0" err="1"/>
+              <a:t>uscore</a:t>
+            </a:r>
+            <a:r>
+              <a:rPr lang="en-US" sz="1400" b="1" dirty="0"/>
+              <a:t> 6.1.0</a:t>
+            </a:r>
+          </a:p>
+        </p:txBody>
+      </p:sp>
+      <p:sp>
+        <p:nvSpPr>
+          <p:cNvPr id="11" name="Rectangle 10">
+            <a:extLst>
+              <a:ext uri="{FF2B5EF4-FFF2-40B4-BE49-F238E27FC236}">
+                <a16:creationId xmlns:a16="http://schemas.microsoft.com/office/drawing/2014/main" id="{8FBEE61F-5DC4-9B6B-6C14-4C2181AA6FED}"/>
+              </a:ext>
+            </a:extLst>
+          </p:cNvPr>
+          <p:cNvSpPr/>
+          <p:nvPr/>
+        </p:nvSpPr>
+        <p:spPr>
+          <a:xfrm>
+            <a:off x="7160344" y="2144243"/>
+            <a:ext cx="1635845" cy="728551"/>
+          </a:xfrm>
+          <a:prstGeom prst="rect">
+            <a:avLst/>
+          </a:prstGeom>
+        </p:spPr>
+        <p:style>
+          <a:lnRef idx="1">
+            <a:schemeClr val="accent1"/>
+          </a:lnRef>
+          <a:fillRef idx="3">
+            <a:schemeClr val="accent1"/>
+          </a:fillRef>
+          <a:effectRef idx="2">
+            <a:schemeClr val="accent1"/>
+          </a:effectRef>
+          <a:fontRef idx="minor">
+            <a:schemeClr val="lt1"/>
+          </a:fontRef>
+        </p:style>
+        <p:txBody>
+          <a:bodyPr rtlCol="0" anchor="ctr"/>
+          <a:lstStyle/>
+          <a:p>
+            <a:pPr algn="ctr"/>
+            <a:r>
+              <a:rPr lang="en-US" dirty="0"/>
+              <a:t>Create new VS Package</a:t>
+            </a:r>
+          </a:p>
+        </p:txBody>
+      </p:sp>
       <p:cxnSp>
         <p:nvCxnSpPr>
-          <p:cNvPr id="32" name="Straight Arrow Connector 31">
+          <p:cNvPr id="12" name="Straight Arrow Connector 11">
             <a:extLst>
               <a:ext uri="{FF2B5EF4-FFF2-40B4-BE49-F238E27FC236}">
-                <a16:creationId xmlns:a16="http://schemas.microsoft.com/office/drawing/2014/main" id="{22D37343-E4A8-DE4B-3A28-1946FD994307}"/>
+                <a16:creationId xmlns:a16="http://schemas.microsoft.com/office/drawing/2014/main" id="{24ED2CEB-9FC8-B446-FE3B-7542B28CF52D}"/>
               </a:ext>
             </a:extLst>
           </p:cNvPr>
           <p:cNvCxnSpPr>
             <a:cxnSpLocks/>
-            <a:stCxn id="26" idx="2"/>
+            <a:stCxn id="11" idx="1"/>
           </p:cNvCxnSpPr>
           <p:nvPr/>
         </p:nvCxnSpPr>
         <p:spPr>
-          <a:xfrm>
-            <a:off x="1983658" y="2693551"/>
-            <a:ext cx="149941" cy="836556"/>
+          <a:xfrm flipH="1">
+            <a:off x="6442586" y="2508519"/>
+            <a:ext cx="717758" cy="1351939"/>
           </a:xfrm>
           <a:prstGeom prst="straightConnector1">
             <a:avLst/>
@@ -3697,53 +3824,6 @@
           </a:fontRef>
         </p:style>
       </p:cxnSp>
-      <p:sp>
-        <p:nvSpPr>
-          <p:cNvPr id="2" name="Rectangle 1">
-            <a:extLst>
-              <a:ext uri="{FF2B5EF4-FFF2-40B4-BE49-F238E27FC236}">
-                <a16:creationId xmlns:a16="http://schemas.microsoft.com/office/drawing/2014/main" id="{76D42D34-64FA-B0FE-4702-43CBCF88FF35}"/>
-              </a:ext>
-            </a:extLst>
-          </p:cNvPr>
-          <p:cNvSpPr/>
-          <p:nvPr/>
-        </p:nvSpPr>
-        <p:spPr>
-          <a:xfrm>
-            <a:off x="5800725" y="3882118"/>
-            <a:ext cx="1114425" cy="286757"/>
-          </a:xfrm>
-          <a:prstGeom prst="rect">
-            <a:avLst/>
-          </a:prstGeom>
-        </p:spPr>
-        <p:style>
-          <a:lnRef idx="1">
-            <a:schemeClr val="accent1"/>
-          </a:lnRef>
-          <a:fillRef idx="3">
-            <a:schemeClr val="accent1"/>
-          </a:fillRef>
-          <a:effectRef idx="2">
-            <a:schemeClr val="accent1"/>
-          </a:effectRef>
-          <a:fontRef idx="minor">
-            <a:schemeClr val="lt1"/>
-          </a:fontRef>
-        </p:style>
-        <p:txBody>
-          <a:bodyPr rtlCol="0" anchor="ctr"/>
-          <a:lstStyle/>
-          <a:p>
-            <a:pPr algn="ctr"/>
-            <a:r>
-              <a:rPr lang="en-US" dirty="0"/>
-              <a:t>Create</a:t>
-            </a:r>
-          </a:p>
-        </p:txBody>
-      </p:sp>
     </p:spTree>
     <p:extLst>
       <p:ext uri="{BB962C8B-B14F-4D97-AF65-F5344CB8AC3E}">
@@ -3877,10 +3957,10 @@
       </p:sp>
       <p:pic>
         <p:nvPicPr>
-          <p:cNvPr id="21" name="Picture 20">
+          <p:cNvPr id="3" name="Picture 2">
             <a:extLst>
               <a:ext uri="{FF2B5EF4-FFF2-40B4-BE49-F238E27FC236}">
-                <a16:creationId xmlns:a16="http://schemas.microsoft.com/office/drawing/2014/main" id="{F4A880E7-BB5F-E557-9430-31F4F839A286}"/>
+                <a16:creationId xmlns:a16="http://schemas.microsoft.com/office/drawing/2014/main" id="{D51C9208-19ED-DC1B-E093-4CB87B83786F}"/>
               </a:ext>
             </a:extLst>
           </p:cNvPr>
@@ -3897,8 +3977,8 @@
         </p:blipFill>
         <p:spPr>
           <a:xfrm>
-            <a:off x="1054408" y="3466060"/>
-            <a:ext cx="6791734" cy="3190398"/>
+            <a:off x="0" y="1351223"/>
+            <a:ext cx="9144000" cy="1087887"/>
           </a:xfrm>
           <a:prstGeom prst="rect">
             <a:avLst/>
@@ -3917,10 +3997,10 @@
       </p:pic>
       <p:pic>
         <p:nvPicPr>
-          <p:cNvPr id="26" name="Picture 25">
+          <p:cNvPr id="9" name="Picture 8">
             <a:extLst>
               <a:ext uri="{FF2B5EF4-FFF2-40B4-BE49-F238E27FC236}">
-                <a16:creationId xmlns:a16="http://schemas.microsoft.com/office/drawing/2014/main" id="{31B2F7A1-813C-24F6-A695-9F3C14831252}"/>
+                <a16:creationId xmlns:a16="http://schemas.microsoft.com/office/drawing/2014/main" id="{69ED0AFC-0E1D-0AF6-12EE-B4D78320E4F6}"/>
               </a:ext>
             </a:extLst>
           </p:cNvPr>
@@ -3937,8 +4017,8 @@
         </p:blipFill>
         <p:spPr>
           <a:xfrm>
-            <a:off x="1031216" y="1240482"/>
-            <a:ext cx="6814925" cy="2225578"/>
+            <a:off x="0" y="2439110"/>
+            <a:ext cx="9144000" cy="3546039"/>
           </a:xfrm>
           <a:prstGeom prst="rect">
             <a:avLst/>
@@ -3947,10 +4027,10 @@
       </p:pic>
       <p:sp>
         <p:nvSpPr>
-          <p:cNvPr id="27" name="Rectangle 26">
+          <p:cNvPr id="10" name="Rectangle 9">
             <a:extLst>
               <a:ext uri="{FF2B5EF4-FFF2-40B4-BE49-F238E27FC236}">
-                <a16:creationId xmlns:a16="http://schemas.microsoft.com/office/drawing/2014/main" id="{5FF642DA-4A29-E90C-67F9-8B98B7199B2A}"/>
+                <a16:creationId xmlns:a16="http://schemas.microsoft.com/office/drawing/2014/main" id="{F3CDF554-D8F3-1702-AA30-8016F4B1EE82}"/>
               </a:ext>
             </a:extLst>
           </p:cNvPr>
@@ -3959,39 +4039,75 @@
         </p:nvSpPr>
         <p:spPr>
           <a:xfrm>
-            <a:off x="1986116" y="1240482"/>
-            <a:ext cx="1750142" cy="489995"/>
+            <a:off x="7934015" y="5841770"/>
+            <a:ext cx="1114425" cy="286757"/>
+          </a:xfrm>
+          <a:prstGeom prst="rect">
+            <a:avLst/>
+          </a:prstGeom>
+        </p:spPr>
+        <p:style>
+          <a:lnRef idx="1">
+            <a:schemeClr val="accent1"/>
+          </a:lnRef>
+          <a:fillRef idx="3">
+            <a:schemeClr val="accent1"/>
+          </a:fillRef>
+          <a:effectRef idx="2">
+            <a:schemeClr val="accent1"/>
+          </a:effectRef>
+          <a:fontRef idx="minor">
+            <a:schemeClr val="lt1"/>
+          </a:fontRef>
+        </p:style>
+        <p:txBody>
+          <a:bodyPr rtlCol="0" anchor="ctr"/>
+          <a:lstStyle/>
+          <a:p>
+            <a:pPr algn="ctr"/>
+            <a:r>
+              <a:rPr lang="en-US" dirty="0"/>
+              <a:t>Create</a:t>
+            </a:r>
+          </a:p>
+        </p:txBody>
+      </p:sp>
+      <p:sp>
+        <p:nvSpPr>
+          <p:cNvPr id="12" name="TextBox 11">
+            <a:extLst>
+              <a:ext uri="{FF2B5EF4-FFF2-40B4-BE49-F238E27FC236}">
+                <a16:creationId xmlns:a16="http://schemas.microsoft.com/office/drawing/2014/main" id="{D69D8D9F-E1FF-E3FA-86E4-076664914D25}"/>
+              </a:ext>
+            </a:extLst>
+          </p:cNvPr>
+          <p:cNvSpPr txBox="1"/>
+          <p:nvPr/>
+        </p:nvSpPr>
+        <p:spPr>
+          <a:xfrm>
+            <a:off x="1020009" y="5233851"/>
+            <a:ext cx="4823821" cy="523220"/>
           </a:xfrm>
           <a:prstGeom prst="rect">
             <a:avLst/>
           </a:prstGeom>
           <a:noFill/>
-          <a:ln w="28575">
-            <a:solidFill>
-              <a:srgbClr val="FF0000"/>
-            </a:solidFill>
-          </a:ln>
-        </p:spPr>
-        <p:style>
-          <a:lnRef idx="0">
-            <a:scrgbClr r="0" g="0" b="0"/>
-          </a:lnRef>
-          <a:fillRef idx="0">
-            <a:scrgbClr r="0" g="0" b="0"/>
-          </a:fillRef>
-          <a:effectRef idx="0">
-            <a:scrgbClr r="0" g="0" b="0"/>
-          </a:effectRef>
-          <a:fontRef idx="minor">
-            <a:schemeClr val="dk1"/>
-          </a:fontRef>
-        </p:style>
-        <p:txBody>
-          <a:bodyPr rtlCol="0" anchor="ctr"/>
-          <a:lstStyle/>
-          <a:p>
-            <a:pPr algn="ctr"/>
-            <a:endParaRPr lang="en-US"/>
+        </p:spPr>
+        <p:txBody>
+          <a:bodyPr wrap="none" rtlCol="0">
+            <a:spAutoFit/>
+          </a:bodyPr>
+          <a:lstStyle/>
+          <a:p>
+            <a:r>
+              <a:rPr lang="en-US" sz="1400" dirty="0"/>
+              <a:t>Manifest from the implementation guide expansion parameters</a:t>
+            </a:r>
+            <a:endParaRPr lang="en-US" sz="1200" dirty="0"/>
+          </a:p>
+          <a:p>
+            <a:endParaRPr lang="en-US" sz="1400" dirty="0"/>
           </a:p>
         </p:txBody>
       </p:sp>
@@ -4570,8 +4686,8 @@
         </p:nvSpPr>
         <p:spPr>
           <a:xfrm>
-            <a:off x="6429374" y="390832"/>
-            <a:ext cx="2425189" cy="873612"/>
+            <a:off x="6228428" y="404576"/>
+            <a:ext cx="2626135" cy="873612"/>
           </a:xfrm>
           <a:prstGeom prst="rect">
             <a:avLst/>
@@ -4607,7 +4723,7 @@
               </a:spcBef>
             </a:pPr>
             <a:r>
-              <a:rPr lang="en-US" sz="1700" kern="1200">
+              <a:rPr lang="en-US" sz="1700" kern="1200" dirty="0">
                 <a:solidFill>
                   <a:srgbClr val="FFFFFF"/>
                 </a:solidFill>
@@ -4615,17 +4731,119 @@
                 <a:ea typeface="+mn-ea"/>
                 <a:cs typeface="+mn-cs"/>
               </a:rPr>
-              <a:t>Home -&gt; Program</a:t>
-            </a:r>
+              <a:t>Home -&gt; </a:t>
+            </a:r>
+            <a:r>
+              <a:rPr lang="en-US" sz="1700" kern="1200" dirty="0" err="1">
+                <a:solidFill>
+                  <a:srgbClr val="FFFFFF"/>
+                </a:solidFill>
+                <a:latin typeface="+mn-lt"/>
+                <a:ea typeface="+mn-ea"/>
+                <a:cs typeface="+mn-cs"/>
+              </a:rPr>
+              <a:t>ValueSet</a:t>
+            </a:r>
+            <a:r>
+              <a:rPr lang="en-US" sz="1700" kern="1200" dirty="0">
+                <a:solidFill>
+                  <a:srgbClr val="FFFFFF"/>
+                </a:solidFill>
+                <a:latin typeface="+mn-lt"/>
+                <a:ea typeface="+mn-ea"/>
+                <a:cs typeface="+mn-cs"/>
+              </a:rPr>
+              <a:t> Packages</a:t>
+            </a:r>
+          </a:p>
+        </p:txBody>
+      </p:sp>
+      <p:sp>
+        <p:nvSpPr>
+          <p:cNvPr id="9" name="TextBox 8">
+            <a:extLst>
+              <a:ext uri="{FF2B5EF4-FFF2-40B4-BE49-F238E27FC236}">
+                <a16:creationId xmlns:a16="http://schemas.microsoft.com/office/drawing/2014/main" id="{1FA4BC77-177D-0695-CE32-EB24135CF3F7}"/>
+              </a:ext>
+            </a:extLst>
+          </p:cNvPr>
+          <p:cNvSpPr txBox="1"/>
+          <p:nvPr/>
+        </p:nvSpPr>
+        <p:spPr>
+          <a:xfrm>
+            <a:off x="255639" y="1562940"/>
+            <a:ext cx="8598924" cy="1754326"/>
+          </a:xfrm>
+          <a:prstGeom prst="rect">
+            <a:avLst/>
+          </a:prstGeom>
+          <a:noFill/>
+        </p:spPr>
+        <p:txBody>
+          <a:bodyPr wrap="square" rtlCol="0">
+            <a:spAutoFit/>
+          </a:bodyPr>
+          <a:lstStyle/>
+          <a:p>
+            <a:pPr marL="285750" indent="-285750">
+              <a:buFont typeface="Arial" panose="020B0604020202020204" pitchFamily="34" charset="0"/>
+              <a:buChar char="•"/>
+            </a:pPr>
+            <a:r>
+              <a:rPr lang="en-US" dirty="0"/>
+              <a:t>Search the list of active value set packages by IG</a:t>
+            </a:r>
+          </a:p>
+          <a:p>
+            <a:pPr marL="285750" indent="-285750">
+              <a:buFont typeface="Arial" panose="020B0604020202020204" pitchFamily="34" charset="0"/>
+              <a:buChar char="•"/>
+            </a:pPr>
+            <a:r>
+              <a:rPr lang="en-US" dirty="0"/>
+              <a:t>Click on Any Value Set Package to review Package Details, </a:t>
+            </a:r>
+            <a:r>
+              <a:rPr lang="en-US" dirty="0" err="1"/>
+              <a:t>ValueSets</a:t>
+            </a:r>
+            <a:r>
+              <a:rPr lang="en-US" dirty="0"/>
+              <a:t>, Metadata &amp; Manifest.</a:t>
+            </a:r>
+          </a:p>
+          <a:p>
+            <a:pPr marL="285750" indent="-285750">
+              <a:buFont typeface="Arial" panose="020B0604020202020204" pitchFamily="34" charset="0"/>
+              <a:buChar char="•"/>
+            </a:pPr>
+            <a:r>
+              <a:rPr lang="en-US" dirty="0"/>
+              <a:t>From inside the Value Set Package, Export – Download the value sets expansions.</a:t>
+            </a:r>
+          </a:p>
+          <a:p>
+            <a:pPr marL="285750" indent="-285750">
+              <a:buFont typeface="Arial" panose="020B0604020202020204" pitchFamily="34" charset="0"/>
+              <a:buChar char="•"/>
+            </a:pPr>
+            <a:r>
+              <a:rPr lang="en-US" dirty="0"/>
+              <a:t>Implementers can only view details, compare versions, view value sets and export</a:t>
+            </a:r>
+          </a:p>
+          <a:p>
+            <a:endParaRPr lang="en-US" dirty="0"/>
           </a:p>
         </p:txBody>
       </p:sp>
       <p:pic>
         <p:nvPicPr>
-          <p:cNvPr id="4" name="Picture 3" descr="A screenshot of a computer&#10;&#10;AI-generated content may be incorrect.">
+          <p:cNvPr id="2" name="Picture 1">
             <a:extLst>
               <a:ext uri="{FF2B5EF4-FFF2-40B4-BE49-F238E27FC236}">
-                <a16:creationId xmlns:a16="http://schemas.microsoft.com/office/drawing/2014/main" id="{D5CDA4AC-B1E9-3C1A-6B61-3E7B175C5235}"/>
+                <a16:creationId xmlns:a16="http://schemas.microsoft.com/office/drawing/2014/main" id="{4247151F-0B8D-DDAC-AB9C-4BAB6D04F07C}"/>
               </a:ext>
             </a:extLst>
           </p:cNvPr>
@@ -4636,26 +4854,69 @@
         </p:nvPicPr>
         <p:blipFill>
           <a:blip r:embed="rId2"/>
+          <a:srcRect b="22738"/>
           <a:stretch>
             <a:fillRect/>
           </a:stretch>
         </p:blipFill>
         <p:spPr>
           <a:xfrm>
-            <a:off x="88491" y="2986550"/>
-            <a:ext cx="8967018" cy="3721313"/>
+            <a:off x="29499" y="4220648"/>
+            <a:ext cx="9144000" cy="2622604"/>
           </a:xfrm>
           <a:prstGeom prst="rect">
             <a:avLst/>
           </a:prstGeom>
         </p:spPr>
       </p:pic>
-      <p:sp>
-        <p:nvSpPr>
-          <p:cNvPr id="7" name="Rectangle 6">
+      <p:cxnSp>
+        <p:nvCxnSpPr>
+          <p:cNvPr id="5" name="Straight Arrow Connector 4">
             <a:extLst>
               <a:ext uri="{FF2B5EF4-FFF2-40B4-BE49-F238E27FC236}">
-                <a16:creationId xmlns:a16="http://schemas.microsoft.com/office/drawing/2014/main" id="{C485F62B-5933-78F7-A927-49CE2813A731}"/>
+                <a16:creationId xmlns:a16="http://schemas.microsoft.com/office/drawing/2014/main" id="{01CFB13C-E68B-77BE-2DCD-F53605639284}"/>
+              </a:ext>
+            </a:extLst>
+          </p:cNvPr>
+          <p:cNvCxnSpPr>
+            <a:cxnSpLocks/>
+            <a:stCxn id="12" idx="2"/>
+          </p:cNvCxnSpPr>
+          <p:nvPr/>
+        </p:nvCxnSpPr>
+        <p:spPr>
+          <a:xfrm>
+            <a:off x="1366688" y="3807708"/>
+            <a:ext cx="196646" cy="2395226"/>
+          </a:xfrm>
+          <a:prstGeom prst="straightConnector1">
+            <a:avLst/>
+          </a:prstGeom>
+          <a:ln>
+            <a:tailEnd type="triangle"/>
+          </a:ln>
+        </p:spPr>
+        <p:style>
+          <a:lnRef idx="2">
+            <a:schemeClr val="accent1"/>
+          </a:lnRef>
+          <a:fillRef idx="0">
+            <a:schemeClr val="accent1"/>
+          </a:fillRef>
+          <a:effectRef idx="1">
+            <a:schemeClr val="accent1"/>
+          </a:effectRef>
+          <a:fontRef idx="minor">
+            <a:schemeClr val="tx1"/>
+          </a:fontRef>
+        </p:style>
+      </p:cxnSp>
+      <p:sp>
+        <p:nvSpPr>
+          <p:cNvPr id="12" name="Rectangle 11">
+            <a:extLst>
+              <a:ext uri="{FF2B5EF4-FFF2-40B4-BE49-F238E27FC236}">
+                <a16:creationId xmlns:a16="http://schemas.microsoft.com/office/drawing/2014/main" id="{6191DC52-1914-FFB3-282C-0B0BD7D2B021}"/>
               </a:ext>
             </a:extLst>
           </p:cNvPr>
@@ -4664,8 +4925,8 @@
         </p:nvSpPr>
         <p:spPr>
           <a:xfrm>
-            <a:off x="2400786" y="3975628"/>
-            <a:ext cx="3077497" cy="319547"/>
+            <a:off x="58998" y="3396328"/>
+            <a:ext cx="2615380" cy="411380"/>
           </a:xfrm>
           <a:prstGeom prst="rect">
             <a:avLst/>
@@ -4689,19 +4950,20 @@
           <a:bodyPr rtlCol="0" anchor="ctr"/>
           <a:lstStyle/>
           <a:p>
-            <a:r>
-              <a:rPr lang="en-US" sz="1400" b="1" dirty="0"/>
-              <a:t>Select Implementation Guide (IG)</a:t>
-            </a:r>
-          </a:p>
-        </p:txBody>
-      </p:sp>
-      <p:sp>
-        <p:nvSpPr>
-          <p:cNvPr id="8" name="Arrow: Pentagon 7">
+            <a:pPr algn="ctr"/>
+            <a:r>
+              <a:rPr lang="en-US" dirty="0"/>
+              <a:t>Review Package Details</a:t>
+            </a:r>
+          </a:p>
+        </p:txBody>
+      </p:sp>
+      <p:sp>
+        <p:nvSpPr>
+          <p:cNvPr id="16" name="Rectangle 15">
             <a:extLst>
               <a:ext uri="{FF2B5EF4-FFF2-40B4-BE49-F238E27FC236}">
-                <a16:creationId xmlns:a16="http://schemas.microsoft.com/office/drawing/2014/main" id="{3626ED08-1211-259F-6174-C480A10659E4}"/>
+                <a16:creationId xmlns:a16="http://schemas.microsoft.com/office/drawing/2014/main" id="{4EA9F911-D754-2A4A-C6C0-AB7E821133D0}"/>
               </a:ext>
             </a:extLst>
           </p:cNvPr>
@@ -4709,11 +4971,57 @@
           <p:nvPr/>
         </p:nvSpPr>
         <p:spPr>
+          <a:xfrm>
+            <a:off x="3967318" y="4911850"/>
+            <a:ext cx="1273276" cy="319547"/>
+          </a:xfrm>
+          <a:prstGeom prst="rect">
+            <a:avLst/>
+          </a:prstGeom>
+        </p:spPr>
+        <p:style>
+          <a:lnRef idx="1">
+            <a:schemeClr val="accent1"/>
+          </a:lnRef>
+          <a:fillRef idx="3">
+            <a:schemeClr val="accent1"/>
+          </a:fillRef>
+          <a:effectRef idx="2">
+            <a:schemeClr val="accent1"/>
+          </a:effectRef>
+          <a:fontRef idx="minor">
+            <a:schemeClr val="lt1"/>
+          </a:fontRef>
+        </p:style>
+        <p:txBody>
+          <a:bodyPr rtlCol="0" anchor="ctr"/>
+          <a:lstStyle/>
+          <a:p>
+            <a:r>
+              <a:rPr lang="en-US" sz="1400" b="1" dirty="0"/>
+              <a:t>Select IG</a:t>
+            </a:r>
+          </a:p>
+        </p:txBody>
+      </p:sp>
+      <p:sp>
+        <p:nvSpPr>
+          <p:cNvPr id="18" name="Rectangle 17">
+            <a:extLst>
+              <a:ext uri="{FF2B5EF4-FFF2-40B4-BE49-F238E27FC236}">
+                <a16:creationId xmlns:a16="http://schemas.microsoft.com/office/drawing/2014/main" id="{08A0B3C3-E7A6-7AE1-7C82-8FCACE77AC18}"/>
+              </a:ext>
+            </a:extLst>
+          </p:cNvPr>
+          <p:cNvSpPr/>
+          <p:nvPr/>
+        </p:nvSpPr>
+        <p:spPr>
           <a:xfrm rot="5400000">
-            <a:off x="5243168" y="4045198"/>
-            <a:ext cx="155602" cy="180406"/>
-          </a:xfrm>
-          <a:prstGeom prst="homePlate">
+            <a:off x="4984954" y="4993433"/>
+            <a:ext cx="155603" cy="159028"/>
+          </a:xfrm>
+          <a:prstGeom prst="rect">
             <a:avLst/>
           </a:prstGeom>
         </p:spPr>
@@ -4744,84 +5052,194 @@
       </p:sp>
       <p:sp>
         <p:nvSpPr>
-          <p:cNvPr id="9" name="TextBox 8">
+          <p:cNvPr id="19" name="Rectangle 18">
             <a:extLst>
               <a:ext uri="{FF2B5EF4-FFF2-40B4-BE49-F238E27FC236}">
-                <a16:creationId xmlns:a16="http://schemas.microsoft.com/office/drawing/2014/main" id="{1FA4BC77-177D-0695-CE32-EB24135CF3F7}"/>
+                <a16:creationId xmlns:a16="http://schemas.microsoft.com/office/drawing/2014/main" id="{871F530E-06D1-8F3A-0847-5C75D8FE7288}"/>
               </a:ext>
             </a:extLst>
           </p:cNvPr>
-          <p:cNvSpPr txBox="1"/>
+          <p:cNvSpPr/>
           <p:nvPr/>
         </p:nvSpPr>
         <p:spPr>
           <a:xfrm>
-            <a:off x="255639" y="1857324"/>
-            <a:ext cx="8598924" cy="1754326"/>
+            <a:off x="6096642" y="5056325"/>
+            <a:ext cx="1114425" cy="286757"/>
           </a:xfrm>
           <a:prstGeom prst="rect">
             <a:avLst/>
           </a:prstGeom>
-          <a:noFill/>
-        </p:spPr>
-        <p:txBody>
-          <a:bodyPr wrap="square" rtlCol="0">
-            <a:spAutoFit/>
-          </a:bodyPr>
-          <a:lstStyle/>
-          <a:p>
-            <a:pPr marL="285750" indent="-285750">
-              <a:buFont typeface="Arial" panose="020B0604020202020204" pitchFamily="34" charset="0"/>
-              <a:buChar char="•"/>
-            </a:pPr>
+        </p:spPr>
+        <p:style>
+          <a:lnRef idx="1">
+            <a:schemeClr val="accent1"/>
+          </a:lnRef>
+          <a:fillRef idx="3">
+            <a:schemeClr val="accent1"/>
+          </a:fillRef>
+          <a:effectRef idx="2">
+            <a:schemeClr val="accent1"/>
+          </a:effectRef>
+          <a:fontRef idx="minor">
+            <a:schemeClr val="lt1"/>
+          </a:fontRef>
+        </p:style>
+        <p:txBody>
+          <a:bodyPr rtlCol="0" anchor="ctr"/>
+          <a:lstStyle/>
+          <a:p>
+            <a:pPr algn="ctr"/>
             <a:r>
               <a:rPr lang="en-US" dirty="0"/>
-              <a:t>Search the list of active value set packages by IG</a:t>
-            </a:r>
-          </a:p>
-          <a:p>
-            <a:pPr marL="285750" indent="-285750">
-              <a:buFont typeface="Arial" panose="020B0604020202020204" pitchFamily="34" charset="0"/>
-              <a:buChar char="•"/>
-            </a:pPr>
+              <a:t>Create</a:t>
+            </a:r>
+          </a:p>
+        </p:txBody>
+      </p:sp>
+      <p:sp>
+        <p:nvSpPr>
+          <p:cNvPr id="20" name="Rectangle 19">
+            <a:extLst>
+              <a:ext uri="{FF2B5EF4-FFF2-40B4-BE49-F238E27FC236}">
+                <a16:creationId xmlns:a16="http://schemas.microsoft.com/office/drawing/2014/main" id="{DBEFBB79-2946-A03A-E2C6-42BB915ADDED}"/>
+              </a:ext>
+            </a:extLst>
+          </p:cNvPr>
+          <p:cNvSpPr/>
+          <p:nvPr/>
+        </p:nvSpPr>
+        <p:spPr>
+          <a:xfrm>
+            <a:off x="3967318" y="5231397"/>
+            <a:ext cx="1273276" cy="319547"/>
+          </a:xfrm>
+          <a:prstGeom prst="rect">
+            <a:avLst/>
+          </a:prstGeom>
+        </p:spPr>
+        <p:style>
+          <a:lnRef idx="1">
+            <a:schemeClr val="accent1"/>
+          </a:lnRef>
+          <a:fillRef idx="3">
+            <a:schemeClr val="accent1"/>
+          </a:fillRef>
+          <a:effectRef idx="2">
+            <a:schemeClr val="accent1"/>
+          </a:effectRef>
+          <a:fontRef idx="minor">
+            <a:schemeClr val="lt1"/>
+          </a:fontRef>
+        </p:style>
+        <p:txBody>
+          <a:bodyPr rtlCol="0" anchor="ctr"/>
+          <a:lstStyle/>
+          <a:p>
+            <a:r>
+              <a:rPr lang="en-US" sz="1400" b="1" dirty="0" err="1"/>
+              <a:t>uscore</a:t>
+            </a:r>
+            <a:r>
+              <a:rPr lang="en-US" sz="1400" b="1" dirty="0"/>
+              <a:t> 6.1.0</a:t>
+            </a:r>
+          </a:p>
+        </p:txBody>
+      </p:sp>
+      <p:sp>
+        <p:nvSpPr>
+          <p:cNvPr id="21" name="Rectangle 20">
+            <a:extLst>
+              <a:ext uri="{FF2B5EF4-FFF2-40B4-BE49-F238E27FC236}">
+                <a16:creationId xmlns:a16="http://schemas.microsoft.com/office/drawing/2014/main" id="{A23860A7-A245-9E71-96DA-E24E8AE05369}"/>
+              </a:ext>
+            </a:extLst>
+          </p:cNvPr>
+          <p:cNvSpPr/>
+          <p:nvPr/>
+        </p:nvSpPr>
+        <p:spPr>
+          <a:xfrm>
+            <a:off x="2936153" y="3233088"/>
+            <a:ext cx="1635845" cy="728551"/>
+          </a:xfrm>
+          <a:prstGeom prst="rect">
+            <a:avLst/>
+          </a:prstGeom>
+        </p:spPr>
+        <p:style>
+          <a:lnRef idx="1">
+            <a:schemeClr val="accent1"/>
+          </a:lnRef>
+          <a:fillRef idx="3">
+            <a:schemeClr val="accent1"/>
+          </a:fillRef>
+          <a:effectRef idx="2">
+            <a:schemeClr val="accent1"/>
+          </a:effectRef>
+          <a:fontRef idx="minor">
+            <a:schemeClr val="lt1"/>
+          </a:fontRef>
+        </p:style>
+        <p:txBody>
+          <a:bodyPr rtlCol="0" anchor="ctr"/>
+          <a:lstStyle/>
+          <a:p>
+            <a:pPr algn="ctr"/>
             <a:r>
               <a:rPr lang="en-US" dirty="0"/>
-              <a:t>Click on Any Value Set Package to review Package Details, </a:t>
+              <a:t>Export, View </a:t>
             </a:r>
             <a:r>
               <a:rPr lang="en-US" dirty="0" err="1"/>
               <a:t>ValueSets</a:t>
             </a:r>
-            <a:r>
-              <a:rPr lang="en-US" dirty="0"/>
-              <a:t>, Metadata &amp; Manifest.</a:t>
-            </a:r>
-          </a:p>
-          <a:p>
-            <a:pPr marL="285750" indent="-285750">
-              <a:buFont typeface="Arial" panose="020B0604020202020204" pitchFamily="34" charset="0"/>
-              <a:buChar char="•"/>
-            </a:pPr>
-            <a:r>
-              <a:rPr lang="en-US" dirty="0"/>
-              <a:t>From inside the Value Set Package, Export – Download the value sets expansions.</a:t>
-            </a:r>
-          </a:p>
-          <a:p>
-            <a:pPr marL="285750" indent="-285750">
-              <a:buFont typeface="Arial" panose="020B0604020202020204" pitchFamily="34" charset="0"/>
-              <a:buChar char="•"/>
-            </a:pPr>
-            <a:r>
-              <a:rPr lang="en-US" dirty="0"/>
-              <a:t>Implementers can only view details, compare versions, view value sets and export</a:t>
-            </a:r>
-          </a:p>
-          <a:p>
             <a:endParaRPr lang="en-US" dirty="0"/>
           </a:p>
         </p:txBody>
       </p:sp>
+      <p:cxnSp>
+        <p:nvCxnSpPr>
+          <p:cNvPr id="22" name="Straight Arrow Connector 21">
+            <a:extLst>
+              <a:ext uri="{FF2B5EF4-FFF2-40B4-BE49-F238E27FC236}">
+                <a16:creationId xmlns:a16="http://schemas.microsoft.com/office/drawing/2014/main" id="{C25EEA5E-63D1-5E56-D222-8EE1730ED19E}"/>
+              </a:ext>
+            </a:extLst>
+          </p:cNvPr>
+          <p:cNvCxnSpPr>
+            <a:cxnSpLocks/>
+          </p:cNvCxnSpPr>
+          <p:nvPr/>
+        </p:nvCxnSpPr>
+        <p:spPr>
+          <a:xfrm flipH="1">
+            <a:off x="1679168" y="4017107"/>
+            <a:ext cx="1907152" cy="2172298"/>
+          </a:xfrm>
+          <a:prstGeom prst="straightConnector1">
+            <a:avLst/>
+          </a:prstGeom>
+          <a:ln>
+            <a:tailEnd type="triangle"/>
+          </a:ln>
+        </p:spPr>
+        <p:style>
+          <a:lnRef idx="2">
+            <a:schemeClr val="accent1"/>
+          </a:lnRef>
+          <a:fillRef idx="0">
+            <a:schemeClr val="accent1"/>
+          </a:fillRef>
+          <a:effectRef idx="1">
+            <a:schemeClr val="accent1"/>
+          </a:effectRef>
+          <a:fontRef idx="minor">
+            <a:schemeClr val="tx1"/>
+          </a:fontRef>
+        </p:style>
+      </p:cxnSp>
     </p:spTree>
     <p:extLst>
       <p:ext uri="{BB962C8B-B14F-4D97-AF65-F5344CB8AC3E}">

</xml_diff>